<commit_message>
Updated FX PB PBI Report
</commit_message>
<xml_diff>
--- a/fx-prime-brokerage-collateral/presentation/fx-primer-broker-collateral.pptx
+++ b/fx-prime-brokerage-collateral/presentation/fx-primer-broker-collateral.pptx
@@ -15,22 +15,23 @@
     <p:sldId id="263" r:id="rId9"/>
     <p:sldId id="264" r:id="rId10"/>
     <p:sldId id="265" r:id="rId11"/>
-    <p:sldId id="266" r:id="rId12"/>
+    <p:sldId id="267" r:id="rId12"/>
+    <p:sldId id="266" r:id="rId13"/>
   </p:sldIdLst>
   <p:sldSz cx="18288000" cy="10287000"/>
   <p:notesSz cx="6858000" cy="9144000"/>
   <p:embeddedFontLst>
     <p:embeddedFont>
       <p:font typeface="Montserrat Bold" panose="020B0604020202020204" charset="0"/>
-      <p:regular r:id="rId13"/>
+      <p:regular r:id="rId14"/>
     </p:embeddedFont>
     <p:embeddedFont>
       <p:font typeface="Poppins" panose="00000500000000000000" pitchFamily="2" charset="0"/>
-      <p:regular r:id="rId14"/>
+      <p:regular r:id="rId15"/>
     </p:embeddedFont>
     <p:embeddedFont>
       <p:font typeface="Poppins Bold" panose="020B0604020202020204" charset="0"/>
-      <p:regular r:id="rId15"/>
+      <p:regular r:id="rId16"/>
     </p:embeddedFont>
   </p:embeddedFontLst>
   <p:defaultTextStyle>
@@ -327,7 +328,7 @@
             <a:fld id="{1D8BD707-D9CF-40AE-B4C6-C98DA3205C09}" type="datetimeFigureOut">
               <a:rPr lang="en-US" smtClean="0"/>
               <a:pPr/>
-              <a:t>8/10/2026</a:t>
+              <a:t>8/12/2026</a:t>
             </a:fld>
             <a:endParaRPr lang="en-US"/>
           </a:p>
@@ -492,7 +493,7 @@
             <a:fld id="{1D8BD707-D9CF-40AE-B4C6-C98DA3205C09}" type="datetimeFigureOut">
               <a:rPr lang="en-US" smtClean="0"/>
               <a:pPr/>
-              <a:t>8/10/2026</a:t>
+              <a:t>8/12/2026</a:t>
             </a:fld>
             <a:endParaRPr lang="en-US"/>
           </a:p>
@@ -667,7 +668,7 @@
             <a:fld id="{1D8BD707-D9CF-40AE-B4C6-C98DA3205C09}" type="datetimeFigureOut">
               <a:rPr lang="en-US" smtClean="0"/>
               <a:pPr/>
-              <a:t>8/10/2026</a:t>
+              <a:t>8/12/2026</a:t>
             </a:fld>
             <a:endParaRPr lang="en-US"/>
           </a:p>
@@ -832,7 +833,7 @@
             <a:fld id="{1D8BD707-D9CF-40AE-B4C6-C98DA3205C09}" type="datetimeFigureOut">
               <a:rPr lang="en-US" smtClean="0"/>
               <a:pPr/>
-              <a:t>8/10/2026</a:t>
+              <a:t>8/12/2026</a:t>
             </a:fld>
             <a:endParaRPr lang="en-US"/>
           </a:p>
@@ -1074,7 +1075,7 @@
             <a:fld id="{1D8BD707-D9CF-40AE-B4C6-C98DA3205C09}" type="datetimeFigureOut">
               <a:rPr lang="en-US" smtClean="0"/>
               <a:pPr/>
-              <a:t>8/10/2026</a:t>
+              <a:t>8/12/2026</a:t>
             </a:fld>
             <a:endParaRPr lang="en-US"/>
           </a:p>
@@ -1356,7 +1357,7 @@
             <a:fld id="{1D8BD707-D9CF-40AE-B4C6-C98DA3205C09}" type="datetimeFigureOut">
               <a:rPr lang="en-US" smtClean="0"/>
               <a:pPr/>
-              <a:t>8/10/2026</a:t>
+              <a:t>8/12/2026</a:t>
             </a:fld>
             <a:endParaRPr lang="en-US"/>
           </a:p>
@@ -1772,7 +1773,7 @@
             <a:fld id="{1D8BD707-D9CF-40AE-B4C6-C98DA3205C09}" type="datetimeFigureOut">
               <a:rPr lang="en-US" smtClean="0"/>
               <a:pPr/>
-              <a:t>8/10/2026</a:t>
+              <a:t>8/12/2026</a:t>
             </a:fld>
             <a:endParaRPr lang="en-US"/>
           </a:p>
@@ -1886,7 +1887,7 @@
             <a:fld id="{1D8BD707-D9CF-40AE-B4C6-C98DA3205C09}" type="datetimeFigureOut">
               <a:rPr lang="en-US" smtClean="0"/>
               <a:pPr/>
-              <a:t>8/10/2026</a:t>
+              <a:t>8/12/2026</a:t>
             </a:fld>
             <a:endParaRPr lang="en-US"/>
           </a:p>
@@ -1978,7 +1979,7 @@
             <a:fld id="{1D8BD707-D9CF-40AE-B4C6-C98DA3205C09}" type="datetimeFigureOut">
               <a:rPr lang="en-US" smtClean="0"/>
               <a:pPr/>
-              <a:t>8/10/2026</a:t>
+              <a:t>8/12/2026</a:t>
             </a:fld>
             <a:endParaRPr lang="en-US"/>
           </a:p>
@@ -2250,7 +2251,7 @@
             <a:fld id="{1D8BD707-D9CF-40AE-B4C6-C98DA3205C09}" type="datetimeFigureOut">
               <a:rPr lang="en-US" smtClean="0"/>
               <a:pPr/>
-              <a:t>8/10/2026</a:t>
+              <a:t>8/12/2026</a:t>
             </a:fld>
             <a:endParaRPr lang="en-US"/>
           </a:p>
@@ -2499,7 +2500,7 @@
             <a:fld id="{1D8BD707-D9CF-40AE-B4C6-C98DA3205C09}" type="datetimeFigureOut">
               <a:rPr lang="en-US" smtClean="0"/>
               <a:pPr/>
-              <a:t>8/10/2026</a:t>
+              <a:t>8/12/2026</a:t>
             </a:fld>
             <a:endParaRPr lang="en-US"/>
           </a:p>
@@ -2707,7 +2708,7 @@
             <a:fld id="{1D8BD707-D9CF-40AE-B4C6-C98DA3205C09}" type="datetimeFigureOut">
               <a:rPr lang="en-US" smtClean="0"/>
               <a:pPr/>
-              <a:t>8/10/2026</a:t>
+              <a:t>8/12/2026</a:t>
             </a:fld>
             <a:endParaRPr lang="en-US"/>
           </a:p>
@@ -3789,6 +3790,743 @@
     </p:bg>
     <p:spTree>
       <p:nvGrpSpPr>
+        <p:cNvPr id="1" name="">
+          <a:extLst>
+            <a:ext uri="{FF2B5EF4-FFF2-40B4-BE49-F238E27FC236}">
+              <a16:creationId xmlns:a16="http://schemas.microsoft.com/office/drawing/2014/main" id="{62BF3AFA-0BDE-1641-4E17-40FA7BDADDC1}"/>
+            </a:ext>
+          </a:extLst>
+        </p:cNvPr>
+        <p:cNvGrpSpPr/>
+        <p:nvPr/>
+      </p:nvGrpSpPr>
+      <p:grpSpPr>
+        <a:xfrm>
+          <a:off x="0" y="0"/>
+          <a:ext cx="0" cy="0"/>
+          <a:chOff x="0" y="0"/>
+          <a:chExt cx="0" cy="0"/>
+        </a:xfrm>
+      </p:grpSpPr>
+      <p:sp>
+        <p:nvSpPr>
+          <p:cNvPr id="6" name="TextBox 6">
+            <a:extLst>
+              <a:ext uri="{FF2B5EF4-FFF2-40B4-BE49-F238E27FC236}">
+                <a16:creationId xmlns:a16="http://schemas.microsoft.com/office/drawing/2014/main" id="{44FC532D-BEB0-B1A3-ECE2-54F80FABBD9A}"/>
+              </a:ext>
+            </a:extLst>
+          </p:cNvPr>
+          <p:cNvSpPr txBox="1"/>
+          <p:nvPr/>
+        </p:nvSpPr>
+        <p:spPr>
+          <a:xfrm>
+            <a:off x="1126711" y="1123950"/>
+            <a:ext cx="16034578" cy="1243930"/>
+          </a:xfrm>
+          <a:prstGeom prst="rect">
+            <a:avLst/>
+          </a:prstGeom>
+        </p:spPr>
+        <p:txBody>
+          <a:bodyPr lIns="0" tIns="0" rIns="0" bIns="0" rtlCol="0" anchor="t">
+            <a:spAutoFit/>
+          </a:bodyPr>
+          <a:lstStyle/>
+          <a:p>
+            <a:pPr algn="ctr">
+              <a:lnSpc>
+                <a:spcPts val="9679"/>
+              </a:lnSpc>
+            </a:pPr>
+            <a:r>
+              <a:rPr lang="en-US" sz="8799" b="1" dirty="0">
+                <a:solidFill>
+                  <a:srgbClr val="EFF1E8"/>
+                </a:solidFill>
+                <a:latin typeface="Montserrat Bold"/>
+                <a:ea typeface="Montserrat Bold"/>
+                <a:cs typeface="Montserrat Bold"/>
+                <a:sym typeface="Montserrat Bold"/>
+              </a:rPr>
+              <a:t>Collateral Dashboard</a:t>
+            </a:r>
+          </a:p>
+        </p:txBody>
+      </p:sp>
+      <p:sp>
+        <p:nvSpPr>
+          <p:cNvPr id="7" name="TextBox 7">
+            <a:extLst>
+              <a:ext uri="{FF2B5EF4-FFF2-40B4-BE49-F238E27FC236}">
+                <a16:creationId xmlns:a16="http://schemas.microsoft.com/office/drawing/2014/main" id="{6F0EEF69-7841-A160-6CB9-118F00FA6561}"/>
+              </a:ext>
+            </a:extLst>
+          </p:cNvPr>
+          <p:cNvSpPr txBox="1"/>
+          <p:nvPr/>
+        </p:nvSpPr>
+        <p:spPr>
+          <a:xfrm>
+            <a:off x="6881427" y="3889779"/>
+            <a:ext cx="4460007" cy="330200"/>
+          </a:xfrm>
+          <a:prstGeom prst="rect">
+            <a:avLst/>
+          </a:prstGeom>
+        </p:spPr>
+        <p:txBody>
+          <a:bodyPr lIns="0" tIns="0" rIns="0" bIns="0" rtlCol="0" anchor="t">
+            <a:spAutoFit/>
+          </a:bodyPr>
+          <a:lstStyle/>
+          <a:p>
+            <a:pPr algn="l">
+              <a:lnSpc>
+                <a:spcPts val="2799"/>
+              </a:lnSpc>
+              <a:spcBef>
+                <a:spcPct val="0"/>
+              </a:spcBef>
+            </a:pPr>
+            <a:r>
+              <a:rPr lang="en-US" sz="1999" b="1">
+                <a:solidFill>
+                  <a:srgbClr val="70A1BD"/>
+                </a:solidFill>
+                <a:latin typeface="Montserrat Bold"/>
+                <a:ea typeface="Montserrat Bold"/>
+                <a:cs typeface="Montserrat Bold"/>
+                <a:sym typeface="Montserrat Bold"/>
+              </a:rPr>
+              <a:t>Manual Screenshotting</a:t>
+            </a:r>
+          </a:p>
+        </p:txBody>
+      </p:sp>
+      <p:sp>
+        <p:nvSpPr>
+          <p:cNvPr id="9" name="TextBox 9">
+            <a:extLst>
+              <a:ext uri="{FF2B5EF4-FFF2-40B4-BE49-F238E27FC236}">
+                <a16:creationId xmlns:a16="http://schemas.microsoft.com/office/drawing/2014/main" id="{908627DA-7994-966C-3E1B-9B27B3C893D3}"/>
+              </a:ext>
+            </a:extLst>
+          </p:cNvPr>
+          <p:cNvSpPr txBox="1"/>
+          <p:nvPr/>
+        </p:nvSpPr>
+        <p:spPr>
+          <a:xfrm>
+            <a:off x="6881427" y="3151934"/>
+            <a:ext cx="875213" cy="712421"/>
+          </a:xfrm>
+          <a:prstGeom prst="rect">
+            <a:avLst/>
+          </a:prstGeom>
+        </p:spPr>
+        <p:txBody>
+          <a:bodyPr lIns="0" tIns="0" rIns="0" bIns="0" rtlCol="0" anchor="t">
+            <a:spAutoFit/>
+          </a:bodyPr>
+          <a:lstStyle/>
+          <a:p>
+            <a:pPr algn="l">
+              <a:lnSpc>
+                <a:spcPts val="5879"/>
+              </a:lnSpc>
+              <a:spcBef>
+                <a:spcPct val="0"/>
+              </a:spcBef>
+            </a:pPr>
+            <a:r>
+              <a:rPr lang="en-US" sz="4199" b="1">
+                <a:solidFill>
+                  <a:srgbClr val="70A1BD"/>
+                </a:solidFill>
+                <a:latin typeface="Montserrat Bold"/>
+                <a:ea typeface="Montserrat Bold"/>
+                <a:cs typeface="Montserrat Bold"/>
+                <a:sym typeface="Montserrat Bold"/>
+              </a:rPr>
+              <a:t>2</a:t>
+            </a:r>
+          </a:p>
+        </p:txBody>
+      </p:sp>
+      <p:sp>
+        <p:nvSpPr>
+          <p:cNvPr id="11" name="TextBox 11">
+            <a:extLst>
+              <a:ext uri="{FF2B5EF4-FFF2-40B4-BE49-F238E27FC236}">
+                <a16:creationId xmlns:a16="http://schemas.microsoft.com/office/drawing/2014/main" id="{9E003D97-6A31-19CA-FE5D-3E369ACDE54D}"/>
+              </a:ext>
+            </a:extLst>
+          </p:cNvPr>
+          <p:cNvSpPr txBox="1"/>
+          <p:nvPr/>
+        </p:nvSpPr>
+        <p:spPr>
+          <a:xfrm>
+            <a:off x="6209974" y="7646895"/>
+            <a:ext cx="4460007" cy="330200"/>
+          </a:xfrm>
+          <a:prstGeom prst="rect">
+            <a:avLst/>
+          </a:prstGeom>
+        </p:spPr>
+        <p:txBody>
+          <a:bodyPr lIns="0" tIns="0" rIns="0" bIns="0" rtlCol="0" anchor="t">
+            <a:spAutoFit/>
+          </a:bodyPr>
+          <a:lstStyle/>
+          <a:p>
+            <a:pPr algn="l">
+              <a:lnSpc>
+                <a:spcPts val="2799"/>
+              </a:lnSpc>
+              <a:spcBef>
+                <a:spcPct val="0"/>
+              </a:spcBef>
+            </a:pPr>
+            <a:r>
+              <a:rPr lang="en-US" sz="1999" b="1">
+                <a:solidFill>
+                  <a:srgbClr val="70A1BD"/>
+                </a:solidFill>
+                <a:latin typeface="Montserrat Bold"/>
+                <a:ea typeface="Montserrat Bold"/>
+                <a:cs typeface="Montserrat Bold"/>
+                <a:sym typeface="Montserrat Bold"/>
+              </a:rPr>
+              <a:t>Teams Pasting &amp; Delays</a:t>
+            </a:r>
+          </a:p>
+        </p:txBody>
+      </p:sp>
+      <p:sp>
+        <p:nvSpPr>
+          <p:cNvPr id="12" name="TextBox 12">
+            <a:extLst>
+              <a:ext uri="{FF2B5EF4-FFF2-40B4-BE49-F238E27FC236}">
+                <a16:creationId xmlns:a16="http://schemas.microsoft.com/office/drawing/2014/main" id="{BA1A5AD4-FE0F-F83B-460A-76C9E29CB7E3}"/>
+              </a:ext>
+            </a:extLst>
+          </p:cNvPr>
+          <p:cNvSpPr txBox="1"/>
+          <p:nvPr/>
+        </p:nvSpPr>
+        <p:spPr>
+          <a:xfrm>
+            <a:off x="6209974" y="8079760"/>
+            <a:ext cx="5926631" cy="1063625"/>
+          </a:xfrm>
+          <a:prstGeom prst="rect">
+            <a:avLst/>
+          </a:prstGeom>
+        </p:spPr>
+        <p:txBody>
+          <a:bodyPr lIns="0" tIns="0" rIns="0" bIns="0" rtlCol="0" anchor="t">
+            <a:spAutoFit/>
+          </a:bodyPr>
+          <a:lstStyle/>
+          <a:p>
+            <a:pPr algn="l">
+              <a:lnSpc>
+                <a:spcPts val="2799"/>
+              </a:lnSpc>
+              <a:spcBef>
+                <a:spcPct val="0"/>
+              </a:spcBef>
+            </a:pPr>
+            <a:r>
+              <a:rPr lang="en-US" sz="1999">
+                <a:solidFill>
+                  <a:srgbClr val="70A1BD"/>
+                </a:solidFill>
+                <a:latin typeface="Poppins"/>
+                <a:ea typeface="Poppins"/>
+                <a:cs typeface="Poppins"/>
+                <a:sym typeface="Poppins"/>
+              </a:rPr>
+              <a:t>Clean incomplete records, remove duplicates, and ensure accuracy to maintain data integrity</a:t>
+            </a:r>
+          </a:p>
+        </p:txBody>
+      </p:sp>
+      <p:sp>
+        <p:nvSpPr>
+          <p:cNvPr id="13" name="TextBox 13">
+            <a:extLst>
+              <a:ext uri="{FF2B5EF4-FFF2-40B4-BE49-F238E27FC236}">
+                <a16:creationId xmlns:a16="http://schemas.microsoft.com/office/drawing/2014/main" id="{9C3744FB-5205-1D00-93EF-693E60C677D6}"/>
+              </a:ext>
+            </a:extLst>
+          </p:cNvPr>
+          <p:cNvSpPr txBox="1"/>
+          <p:nvPr/>
+        </p:nvSpPr>
+        <p:spPr>
+          <a:xfrm>
+            <a:off x="6209974" y="6909049"/>
+            <a:ext cx="875213" cy="712471"/>
+          </a:xfrm>
+          <a:prstGeom prst="rect">
+            <a:avLst/>
+          </a:prstGeom>
+        </p:spPr>
+        <p:txBody>
+          <a:bodyPr lIns="0" tIns="0" rIns="0" bIns="0" rtlCol="0" anchor="t">
+            <a:spAutoFit/>
+          </a:bodyPr>
+          <a:lstStyle/>
+          <a:p>
+            <a:pPr algn="l">
+              <a:lnSpc>
+                <a:spcPts val="5879"/>
+              </a:lnSpc>
+              <a:spcBef>
+                <a:spcPct val="0"/>
+              </a:spcBef>
+            </a:pPr>
+            <a:r>
+              <a:rPr lang="en-US" sz="4199" b="1">
+                <a:solidFill>
+                  <a:srgbClr val="70A1BD"/>
+                </a:solidFill>
+                <a:latin typeface="Montserrat Bold"/>
+                <a:ea typeface="Montserrat Bold"/>
+                <a:cs typeface="Montserrat Bold"/>
+                <a:sym typeface="Montserrat Bold"/>
+              </a:rPr>
+              <a:t>3</a:t>
+            </a:r>
+          </a:p>
+        </p:txBody>
+      </p:sp>
+      <p:sp>
+        <p:nvSpPr>
+          <p:cNvPr id="17" name="TextBox 17">
+            <a:extLst>
+              <a:ext uri="{FF2B5EF4-FFF2-40B4-BE49-F238E27FC236}">
+                <a16:creationId xmlns:a16="http://schemas.microsoft.com/office/drawing/2014/main" id="{3C4D60B9-7B02-7014-9B22-8467BAD37FA6}"/>
+              </a:ext>
+            </a:extLst>
+          </p:cNvPr>
+          <p:cNvSpPr txBox="1"/>
+          <p:nvPr/>
+        </p:nvSpPr>
+        <p:spPr>
+          <a:xfrm>
+            <a:off x="968689" y="3788319"/>
+            <a:ext cx="4460007" cy="330200"/>
+          </a:xfrm>
+          <a:prstGeom prst="rect">
+            <a:avLst/>
+          </a:prstGeom>
+        </p:spPr>
+        <p:txBody>
+          <a:bodyPr lIns="0" tIns="0" rIns="0" bIns="0" rtlCol="0" anchor="t">
+            <a:spAutoFit/>
+          </a:bodyPr>
+          <a:lstStyle/>
+          <a:p>
+            <a:pPr algn="l">
+              <a:lnSpc>
+                <a:spcPts val="2799"/>
+              </a:lnSpc>
+              <a:spcBef>
+                <a:spcPct val="0"/>
+              </a:spcBef>
+            </a:pPr>
+            <a:r>
+              <a:rPr lang="en-US" sz="1999" b="1">
+                <a:solidFill>
+                  <a:srgbClr val="70A1BD"/>
+                </a:solidFill>
+                <a:latin typeface="Montserrat Bold"/>
+                <a:ea typeface="Montserrat Bold"/>
+                <a:cs typeface="Montserrat Bold"/>
+                <a:sym typeface="Montserrat Bold"/>
+              </a:rPr>
+              <a:t>Portal Authentication</a:t>
+            </a:r>
+          </a:p>
+        </p:txBody>
+      </p:sp>
+      <p:sp>
+        <p:nvSpPr>
+          <p:cNvPr id="19" name="TextBox 19">
+            <a:extLst>
+              <a:ext uri="{FF2B5EF4-FFF2-40B4-BE49-F238E27FC236}">
+                <a16:creationId xmlns:a16="http://schemas.microsoft.com/office/drawing/2014/main" id="{C3812E8F-DF87-F048-B29B-A8C4A382BCEE}"/>
+              </a:ext>
+            </a:extLst>
+          </p:cNvPr>
+          <p:cNvSpPr txBox="1"/>
+          <p:nvPr/>
+        </p:nvSpPr>
+        <p:spPr>
+          <a:xfrm>
+            <a:off x="968689" y="3050474"/>
+            <a:ext cx="875213" cy="712421"/>
+          </a:xfrm>
+          <a:prstGeom prst="rect">
+            <a:avLst/>
+          </a:prstGeom>
+        </p:spPr>
+        <p:txBody>
+          <a:bodyPr lIns="0" tIns="0" rIns="0" bIns="0" rtlCol="0" anchor="t">
+            <a:spAutoFit/>
+          </a:bodyPr>
+          <a:lstStyle/>
+          <a:p>
+            <a:pPr algn="l">
+              <a:lnSpc>
+                <a:spcPts val="5879"/>
+              </a:lnSpc>
+              <a:spcBef>
+                <a:spcPct val="0"/>
+              </a:spcBef>
+            </a:pPr>
+            <a:r>
+              <a:rPr lang="en-US" sz="4199" b="1">
+                <a:solidFill>
+                  <a:srgbClr val="70A1BD"/>
+                </a:solidFill>
+                <a:latin typeface="Montserrat Bold"/>
+                <a:ea typeface="Montserrat Bold"/>
+                <a:cs typeface="Montserrat Bold"/>
+                <a:sym typeface="Montserrat Bold"/>
+              </a:rPr>
+              <a:t>1</a:t>
+            </a:r>
+          </a:p>
+        </p:txBody>
+      </p:sp>
+      <p:sp>
+        <p:nvSpPr>
+          <p:cNvPr id="23" name="TextBox 23">
+            <a:extLst>
+              <a:ext uri="{FF2B5EF4-FFF2-40B4-BE49-F238E27FC236}">
+                <a16:creationId xmlns:a16="http://schemas.microsoft.com/office/drawing/2014/main" id="{5EA874EE-4800-BBB3-8512-F9064730E99B}"/>
+              </a:ext>
+            </a:extLst>
+          </p:cNvPr>
+          <p:cNvSpPr txBox="1"/>
+          <p:nvPr/>
+        </p:nvSpPr>
+        <p:spPr>
+          <a:xfrm>
+            <a:off x="10894469" y="3788319"/>
+            <a:ext cx="4460007" cy="330200"/>
+          </a:xfrm>
+          <a:prstGeom prst="rect">
+            <a:avLst/>
+          </a:prstGeom>
+        </p:spPr>
+        <p:txBody>
+          <a:bodyPr lIns="0" tIns="0" rIns="0" bIns="0" rtlCol="0" anchor="t">
+            <a:spAutoFit/>
+          </a:bodyPr>
+          <a:lstStyle/>
+          <a:p>
+            <a:pPr algn="l">
+              <a:lnSpc>
+                <a:spcPts val="2799"/>
+              </a:lnSpc>
+              <a:spcBef>
+                <a:spcPct val="0"/>
+              </a:spcBef>
+            </a:pPr>
+            <a:r>
+              <a:rPr lang="en-US" sz="1999" b="1">
+                <a:solidFill>
+                  <a:srgbClr val="70A1BD"/>
+                </a:solidFill>
+                <a:latin typeface="Montserrat Bold"/>
+                <a:ea typeface="Montserrat Bold"/>
+                <a:cs typeface="Montserrat Bold"/>
+                <a:sym typeface="Montserrat Bold"/>
+              </a:rPr>
+              <a:t>Manual Screenshotting</a:t>
+            </a:r>
+          </a:p>
+        </p:txBody>
+      </p:sp>
+      <p:sp>
+        <p:nvSpPr>
+          <p:cNvPr id="24" name="TextBox 24">
+            <a:extLst>
+              <a:ext uri="{FF2B5EF4-FFF2-40B4-BE49-F238E27FC236}">
+                <a16:creationId xmlns:a16="http://schemas.microsoft.com/office/drawing/2014/main" id="{8A7487A4-C215-44EF-2B3E-D56648337F9F}"/>
+              </a:ext>
+            </a:extLst>
+          </p:cNvPr>
+          <p:cNvSpPr txBox="1"/>
+          <p:nvPr/>
+        </p:nvSpPr>
+        <p:spPr>
+          <a:xfrm>
+            <a:off x="10894469" y="4221184"/>
+            <a:ext cx="5926631" cy="711200"/>
+          </a:xfrm>
+          <a:prstGeom prst="rect">
+            <a:avLst/>
+          </a:prstGeom>
+        </p:spPr>
+        <p:txBody>
+          <a:bodyPr lIns="0" tIns="0" rIns="0" bIns="0" rtlCol="0" anchor="t">
+            <a:spAutoFit/>
+          </a:bodyPr>
+          <a:lstStyle/>
+          <a:p>
+            <a:pPr algn="l">
+              <a:lnSpc>
+                <a:spcPts val="2799"/>
+              </a:lnSpc>
+              <a:spcBef>
+                <a:spcPct val="0"/>
+              </a:spcBef>
+            </a:pPr>
+            <a:r>
+              <a:rPr lang="en-US" sz="1999">
+                <a:solidFill>
+                  <a:srgbClr val="70A1BD"/>
+                </a:solidFill>
+                <a:latin typeface="Poppins"/>
+                <a:ea typeface="Poppins"/>
+                <a:cs typeface="Poppins"/>
+                <a:sym typeface="Poppins"/>
+              </a:rPr>
+              <a:t>Gather relevant quantitative and qualitative data from internal and external sources</a:t>
+            </a:r>
+          </a:p>
+        </p:txBody>
+      </p:sp>
+      <p:sp>
+        <p:nvSpPr>
+          <p:cNvPr id="25" name="TextBox 25">
+            <a:extLst>
+              <a:ext uri="{FF2B5EF4-FFF2-40B4-BE49-F238E27FC236}">
+                <a16:creationId xmlns:a16="http://schemas.microsoft.com/office/drawing/2014/main" id="{247159C3-C726-E735-6C32-ED4A8922E3A4}"/>
+              </a:ext>
+            </a:extLst>
+          </p:cNvPr>
+          <p:cNvSpPr txBox="1"/>
+          <p:nvPr/>
+        </p:nvSpPr>
+        <p:spPr>
+          <a:xfrm>
+            <a:off x="10894469" y="3050474"/>
+            <a:ext cx="875213" cy="712471"/>
+          </a:xfrm>
+          <a:prstGeom prst="rect">
+            <a:avLst/>
+          </a:prstGeom>
+        </p:spPr>
+        <p:txBody>
+          <a:bodyPr lIns="0" tIns="0" rIns="0" bIns="0" rtlCol="0" anchor="t">
+            <a:spAutoFit/>
+          </a:bodyPr>
+          <a:lstStyle/>
+          <a:p>
+            <a:pPr algn="l">
+              <a:lnSpc>
+                <a:spcPts val="5879"/>
+              </a:lnSpc>
+              <a:spcBef>
+                <a:spcPct val="0"/>
+              </a:spcBef>
+            </a:pPr>
+            <a:r>
+              <a:rPr lang="en-US" sz="4199" b="1">
+                <a:solidFill>
+                  <a:srgbClr val="70A1BD"/>
+                </a:solidFill>
+                <a:latin typeface="Montserrat Bold"/>
+                <a:ea typeface="Montserrat Bold"/>
+                <a:cs typeface="Montserrat Bold"/>
+                <a:sym typeface="Montserrat Bold"/>
+              </a:rPr>
+              <a:t>2</a:t>
+            </a:r>
+          </a:p>
+        </p:txBody>
+      </p:sp>
+      <p:sp>
+        <p:nvSpPr>
+          <p:cNvPr id="28" name="Freeform 2">
+            <a:extLst>
+              <a:ext uri="{FF2B5EF4-FFF2-40B4-BE49-F238E27FC236}">
+                <a16:creationId xmlns:a16="http://schemas.microsoft.com/office/drawing/2014/main" id="{F1603938-0620-C97C-2629-CFD42476E3A7}"/>
+              </a:ext>
+            </a:extLst>
+          </p:cNvPr>
+          <p:cNvSpPr/>
+          <p:nvPr/>
+        </p:nvSpPr>
+        <p:spPr>
+          <a:xfrm flipV="1">
+            <a:off x="1028700" y="1028700"/>
+            <a:ext cx="1015236" cy="1015236"/>
+          </a:xfrm>
+          <a:custGeom>
+            <a:avLst/>
+            <a:gdLst/>
+            <a:ahLst/>
+            <a:cxnLst/>
+            <a:rect l="l" t="t" r="r" b="b"/>
+            <a:pathLst>
+              <a:path w="1015236" h="1015236">
+                <a:moveTo>
+                  <a:pt x="0" y="1015236"/>
+                </a:moveTo>
+                <a:lnTo>
+                  <a:pt x="1015236" y="1015236"/>
+                </a:lnTo>
+                <a:lnTo>
+                  <a:pt x="1015236" y="0"/>
+                </a:lnTo>
+                <a:lnTo>
+                  <a:pt x="0" y="0"/>
+                </a:lnTo>
+                <a:lnTo>
+                  <a:pt x="0" y="1015236"/>
+                </a:lnTo>
+                <a:close/>
+              </a:path>
+            </a:pathLst>
+          </a:custGeom>
+          <a:blipFill>
+            <a:blip r:embed="rId2">
+              <a:extLst>
+                <a:ext uri="{96DAC541-7B7A-43D3-8B79-37D633B846F1}">
+                  <asvg:svgBlip xmlns:asvg="http://schemas.microsoft.com/office/drawing/2016/SVG/main" r:embed="rId3"/>
+                </a:ext>
+              </a:extLst>
+            </a:blip>
+            <a:stretch>
+              <a:fillRect/>
+            </a:stretch>
+          </a:blipFill>
+        </p:spPr>
+      </p:sp>
+      <p:sp>
+        <p:nvSpPr>
+          <p:cNvPr id="29" name="Freeform 4">
+            <a:extLst>
+              <a:ext uri="{FF2B5EF4-FFF2-40B4-BE49-F238E27FC236}">
+                <a16:creationId xmlns:a16="http://schemas.microsoft.com/office/drawing/2014/main" id="{C417A0F0-7FAA-788D-700F-B4C76B221DC5}"/>
+              </a:ext>
+            </a:extLst>
+          </p:cNvPr>
+          <p:cNvSpPr/>
+          <p:nvPr/>
+        </p:nvSpPr>
+        <p:spPr>
+          <a:xfrm flipH="1" flipV="1">
+            <a:off x="16244064" y="1028700"/>
+            <a:ext cx="1015236" cy="1015236"/>
+          </a:xfrm>
+          <a:custGeom>
+            <a:avLst/>
+            <a:gdLst/>
+            <a:ahLst/>
+            <a:cxnLst/>
+            <a:rect l="l" t="t" r="r" b="b"/>
+            <a:pathLst>
+              <a:path w="1015236" h="1015236">
+                <a:moveTo>
+                  <a:pt x="1015236" y="1015236"/>
+                </a:moveTo>
+                <a:lnTo>
+                  <a:pt x="0" y="1015236"/>
+                </a:lnTo>
+                <a:lnTo>
+                  <a:pt x="0" y="0"/>
+                </a:lnTo>
+                <a:lnTo>
+                  <a:pt x="1015236" y="0"/>
+                </a:lnTo>
+                <a:lnTo>
+                  <a:pt x="1015236" y="1015236"/>
+                </a:lnTo>
+                <a:close/>
+              </a:path>
+            </a:pathLst>
+          </a:custGeom>
+          <a:blipFill>
+            <a:blip r:embed="rId2">
+              <a:extLst>
+                <a:ext uri="{96DAC541-7B7A-43D3-8B79-37D633B846F1}">
+                  <asvg:svgBlip xmlns:asvg="http://schemas.microsoft.com/office/drawing/2016/SVG/main" r:embed="rId3"/>
+                </a:ext>
+              </a:extLst>
+            </a:blip>
+            <a:stretch>
+              <a:fillRect/>
+            </a:stretch>
+          </a:blipFill>
+        </p:spPr>
+      </p:sp>
+      <p:pic>
+        <p:nvPicPr>
+          <p:cNvPr id="33" name="Picture 32">
+            <a:extLst>
+              <a:ext uri="{FF2B5EF4-FFF2-40B4-BE49-F238E27FC236}">
+                <a16:creationId xmlns:a16="http://schemas.microsoft.com/office/drawing/2014/main" id="{CBDB1FAF-A0C2-299C-5358-52082634EF88}"/>
+              </a:ext>
+            </a:extLst>
+          </p:cNvPr>
+          <p:cNvPicPr>
+            <a:picLocks noChangeAspect="1"/>
+          </p:cNvPicPr>
+          <p:nvPr/>
+        </p:nvPicPr>
+        <p:blipFill>
+          <a:blip r:embed="rId4"/>
+          <a:stretch>
+            <a:fillRect/>
+          </a:stretch>
+        </p:blipFill>
+        <p:spPr>
+          <a:xfrm>
+            <a:off x="2286000" y="2444485"/>
+            <a:ext cx="13716000" cy="7717783"/>
+          </a:xfrm>
+          <a:prstGeom prst="rect">
+            <a:avLst/>
+          </a:prstGeom>
+        </p:spPr>
+      </p:pic>
+    </p:spTree>
+    <p:extLst>
+      <p:ext uri="{BB962C8B-B14F-4D97-AF65-F5344CB8AC3E}">
+        <p14:creationId xmlns:p14="http://schemas.microsoft.com/office/powerpoint/2010/main" val="3168058814"/>
+      </p:ext>
+    </p:extLst>
+  </p:cSld>
+  <p:clrMapOvr>
+    <a:masterClrMapping/>
+  </p:clrMapOvr>
+</p:sld>
+</file>
+
+<file path=ppt/slides/slide12.xml><?xml version="1.0" encoding="utf-8"?>
+<p:sld xmlns:a="http://schemas.openxmlformats.org/drawingml/2006/main" xmlns:r="http://schemas.openxmlformats.org/officeDocument/2006/relationships" xmlns:p="http://schemas.openxmlformats.org/presentationml/2006/main">
+  <p:cSld>
+    <p:bg>
+      <p:bgPr>
+        <a:solidFill>
+          <a:srgbClr val="70A1BD"/>
+        </a:solidFill>
+        <a:effectLst/>
+      </p:bgPr>
+    </p:bg>
+    <p:spTree>
+      <p:nvGrpSpPr>
         <p:cNvPr id="1" name=""/>
         <p:cNvGrpSpPr/>
         <p:nvPr/>
@@ -4012,7 +4750,7 @@
               </a:lnSpc>
             </a:pPr>
             <a:r>
-              <a:rPr lang="en-US" sz="8799" b="1">
+              <a:rPr lang="en-US" sz="8799" b="1" dirty="0">
                 <a:solidFill>
                   <a:srgbClr val="343734"/>
                 </a:solidFill>
@@ -4030,7 +4768,7 @@
                 <a:spcPts val="9679"/>
               </a:lnSpc>
             </a:pPr>
-            <a:endParaRPr lang="en-US" sz="8799" b="1">
+            <a:endParaRPr lang="en-US" sz="8799" b="1" dirty="0">
               <a:solidFill>
                 <a:srgbClr val="343734"/>
               </a:solidFill>
@@ -4333,7 +5071,7 @@
               </a:lnSpc>
             </a:pPr>
             <a:r>
-              <a:rPr lang="en-US" sz="8799" b="1">
+              <a:rPr lang="en-US" sz="8799" b="1" dirty="0">
                 <a:solidFill>
                   <a:srgbClr val="EFF1E8"/>
                 </a:solidFill>
@@ -4351,7 +5089,7 @@
                 <a:spcPts val="9679"/>
               </a:lnSpc>
             </a:pPr>
-            <a:endParaRPr lang="en-US" sz="8799" b="1">
+            <a:endParaRPr lang="en-US" sz="8799" b="1" dirty="0">
               <a:solidFill>
                 <a:srgbClr val="EFF1E8"/>
               </a:solidFill>
@@ -7374,7 +8112,7 @@
         </p:nvGraphicFramePr>
         <p:xfrm>
           <a:off x="961504" y="3923696"/>
-          <a:ext cx="16297796" cy="5991225"/>
+          <a:ext cx="16297797" cy="5991226"/>
         </p:xfrm>
         <a:graphic>
           <a:graphicData uri="http://schemas.openxmlformats.org/drawingml/2006/table">

</xml_diff>